<commit_message>
Expand slide 5 with pact lifecycle and shared streak details
</commit_message>
<xml_diff>
--- a/submission materials/Spot-Project3-Slidedeck.pptx
+++ b/submission materials/Spot-Project3-Slidedeck.pptx
@@ -2315,7 +2315,7 @@
         </p:nvSpPr>
         <p:spPr>
           <a:xfrm>
-            <a:off x="640080" y="502920"/>
+            <a:off x="343151" y="142887"/>
             <a:ext cx="10972800" cy="822960"/>
           </a:xfrm>
           <a:prstGeom prst="rect">
@@ -2496,7 +2496,7 @@
         </p:nvSpPr>
         <p:spPr>
           <a:xfrm>
-            <a:off x="6172200" y="1325880"/>
+            <a:off x="5920991" y="786786"/>
             <a:ext cx="5394960" cy="457200"/>
           </a:xfrm>
           <a:prstGeom prst="rect">
@@ -2535,8 +2535,8 @@
         </p:nvSpPr>
         <p:spPr>
           <a:xfrm>
-            <a:off x="6172200" y="1874520"/>
-            <a:ext cx="5394960" cy="2656383"/>
+            <a:off x="5920990" y="1144909"/>
+            <a:ext cx="5630929" cy="5436762"/>
           </a:xfrm>
           <a:prstGeom prst="rect">
             <a:avLst/>
@@ -2556,38 +2556,36 @@
               <a:buChar char="•"/>
             </a:pPr>
             <a:r>
-              <a:rPr lang="en-US" sz="1600" dirty="0">
-                <a:solidFill>
-                  <a:srgbClr val="262626"/>
-                </a:solidFill>
-                <a:latin typeface="Calibri" pitchFamily="34" charset="0"/>
-                <a:ea typeface="Calibri" pitchFamily="34" charset="-122"/>
-                <a:cs typeface="Calibri" pitchFamily="34" charset="-120"/>
-              </a:rPr>
-              <a:t>Keeping the two halves independent but joined</a:t>
-            </a:r>
-            <a:endParaRPr lang="en-US" sz="1600" dirty="0"/>
-          </a:p>
-          <a:p>
-            <a:pPr marL="508000" lvl="1" indent="-254000">
+              <a:rPr lang="en-US" sz="1500" dirty="0">
+                <a:solidFill>
+                  <a:srgbClr val="262626"/>
+                </a:solidFill>
+                <a:latin typeface="Calibri" pitchFamily="34" charset="0"/>
+                <a:ea typeface="Calibri" pitchFamily="34" charset="-122"/>
+                <a:cs typeface="Calibri" pitchFamily="34" charset="-120"/>
+              </a:rPr>
+              <a:t> Designing the pact lifecycle so both partners have to agree</a:t>
+            </a:r>
+          </a:p>
+          <a:p>
+            <a:pPr marL="711200" lvl="1" indent="-254000">
               <a:spcAft>
-                <a:spcPts val="800"/>
+                <a:spcPts val="200"/>
               </a:spcAft>
               <a:buSzPct val="100000"/>
               <a:buChar char="•"/>
             </a:pPr>
             <a:r>
-              <a:rPr lang="en-US" sz="1600" dirty="0">
-                <a:solidFill>
-                  <a:srgbClr val="262626"/>
-                </a:solidFill>
-                <a:latin typeface="Calibri" pitchFamily="34" charset="0"/>
-                <a:ea typeface="Calibri" pitchFamily="34" charset="-122"/>
-                <a:cs typeface="Calibri" pitchFamily="34" charset="-120"/>
-              </a:rPr>
-              <a:t>Pacts store user _ids and the clearing logic reads them — the ObjectId types have to match exactly or the join silently returns nothing</a:t>
-            </a:r>
-            <a:endParaRPr lang="en-US" sz="1600" dirty="0"/>
+              <a:rPr lang="en-US" sz="1500" dirty="0">
+                <a:solidFill>
+                  <a:srgbClr val="262626"/>
+                </a:solidFill>
+                <a:latin typeface="Calibri" pitchFamily="34" charset="0"/>
+                <a:ea typeface="Calibri" pitchFamily="34" charset="-122"/>
+                <a:cs typeface="Calibri" pitchFamily="34" charset="-120"/>
+              </a:rPr>
+              <a:t>A pact starts pending when one person proposes it and only turns active once the partner accepts, so the dashboard sorts pacts into proposed-by-you, proposed-to-you, and active</a:t>
+            </a:r>
           </a:p>
           <a:p>
             <a:pPr marL="254000" indent="-254000">
@@ -2598,35 +2596,87 @@
               <a:buChar char="•"/>
             </a:pPr>
             <a:r>
-              <a:rPr lang="en-US" sz="1600" dirty="0">
-                <a:solidFill>
-                  <a:srgbClr val="262626"/>
-                </a:solidFill>
-                <a:latin typeface="Calibri" pitchFamily="34" charset="0"/>
-                <a:ea typeface="Calibri" pitchFamily="34" charset="-122"/>
-                <a:cs typeface="Calibri" pitchFamily="34" charset="-120"/>
-              </a:rPr>
-              <a:t>Merging two frontends and session-based auth</a:t>
-            </a:r>
-            <a:endParaRPr lang="en-US" sz="1600" dirty="0"/>
-          </a:p>
-          <a:p>
-            <a:pPr marL="508000" lvl="1" indent="-254000">
-              <a:buSzPct val="100000"/>
-              <a:buChar char="•"/>
-            </a:pPr>
-            <a:r>
-              <a:rPr lang="en-US" sz="1600" dirty="0">
-                <a:solidFill>
-                  <a:srgbClr val="262626"/>
-                </a:solidFill>
-                <a:latin typeface="Calibri" pitchFamily="34" charset="0"/>
-                <a:ea typeface="Calibri" pitchFamily="34" charset="-122"/>
-                <a:cs typeface="Calibri" pitchFamily="34" charset="-120"/>
-              </a:rPr>
-              <a:t>Reconciling a CRA and a Vite + React Router app into one, and switching every route to read the logged-in user from the Passport session</a:t>
-            </a:r>
-            <a:endParaRPr lang="en-US" sz="1600" dirty="0"/>
+              <a:rPr lang="en-US" sz="1500" dirty="0"/>
+              <a:t>Computing a shared streak that breaks for both partners</a:t>
+            </a:r>
+          </a:p>
+          <a:p>
+            <a:pPr marL="711200" lvl="1" indent="-254000">
+              <a:spcAft>
+                <a:spcPts val="200"/>
+              </a:spcAft>
+              <a:buSzPct val="100000"/>
+              <a:buChar char="•"/>
+            </a:pPr>
+            <a:r>
+              <a:rPr lang="en-US" sz="1500" dirty="0"/>
+              <a:t>Counting each partner's sessions per week against the target, where a single missed week resets the streak for both people at once</a:t>
+            </a:r>
+          </a:p>
+          <a:p>
+            <a:pPr marL="711200" lvl="1" indent="-254000">
+              <a:spcAft>
+                <a:spcPts val="200"/>
+              </a:spcAft>
+              <a:buSzPct val="100000"/>
+              <a:buChar char="•"/>
+            </a:pPr>
+            <a:r>
+              <a:rPr lang="en-US" sz="1500" dirty="0"/>
+              <a:t>Learned to normalize every session date to the Monday of its week so the weekly counts line up, and walk backwards week by week to find where the streak breaks</a:t>
+            </a:r>
+          </a:p>
+          <a:p>
+            <a:pPr marL="254000" indent="-254000">
+              <a:spcAft>
+                <a:spcPts val="200"/>
+              </a:spcAft>
+              <a:buSzPct val="100000"/>
+              <a:buChar char="•"/>
+            </a:pPr>
+            <a:r>
+              <a:rPr lang="en-US" sz="1500" dirty="0"/>
+              <a:t>Keeping the two halves joined without shared </a:t>
+            </a:r>
+            <a:r>
+              <a:rPr lang="en-US" sz="1500" dirty="0" err="1"/>
+              <a:t>codE</a:t>
+            </a:r>
+            <a:endParaRPr lang="en-US" sz="1500" dirty="0"/>
+          </a:p>
+          <a:p>
+            <a:pPr marL="711200" lvl="1" indent="-254000">
+              <a:spcAft>
+                <a:spcPts val="200"/>
+              </a:spcAft>
+              <a:buSzPct val="100000"/>
+              <a:buChar char="•"/>
+            </a:pPr>
+            <a:r>
+              <a:rPr lang="en-US" sz="1500" dirty="0"/>
+              <a:t>Pacts store user _ids and the streak logic reads them, so the collections connect purely by ID</a:t>
+            </a:r>
+          </a:p>
+          <a:p>
+            <a:pPr marL="711200" lvl="1" indent="-254000">
+              <a:spcAft>
+                <a:spcPts val="200"/>
+              </a:spcAft>
+              <a:buSzPct val="100000"/>
+              <a:buChar char="•"/>
+            </a:pPr>
+            <a:r>
+              <a:rPr lang="en-US" sz="1500" dirty="0"/>
+              <a:t>Learned to store partner references as native MongoDB </a:t>
+            </a:r>
+            <a:r>
+              <a:rPr lang="en-US" sz="1500" dirty="0" err="1"/>
+              <a:t>ObjectIds</a:t>
+            </a:r>
+            <a:r>
+              <a:rPr lang="en-US" sz="1500" dirty="0"/>
+              <a:t> and query with $or on both partner fields, so a dashboard picks up pacts whether the user proposed them or was invited</a:t>
+            </a:r>
           </a:p>
         </p:txBody>
       </p:sp>

</xml_diff>